<commit_message>
chore: ignore temporary office lock files and update presentation
</commit_message>
<xml_diff>
--- a/SRMIST_FixFlow_Submission.pptx
+++ b/SRMIST_FixFlow_Submission.pptx
@@ -208,7 +208,7 @@
           <a:p>
             <a:fld id="{72CE9A8C-3F50-49F8-A835-316C22A1110D}" type="datetimeFigureOut">
               <a:rPr lang="en-IN" smtClean="0"/>
-              <a:t>08-09-2026</a:t>
+              <a:t>29-09-2026</a:t>
             </a:fld>
             <a:endParaRPr lang="en-IN"/>
           </a:p>
@@ -799,7 +799,7 @@
           <a:p>
             <a:fld id="{2AF27EEE-1B67-445E-AA5D-351EC91D1DEB}" type="datetimeFigureOut">
               <a:rPr lang="en-IN" smtClean="0"/>
-              <a:t>08-09-2026</a:t>
+              <a:t>29-09-2026</a:t>
             </a:fld>
             <a:endParaRPr lang="en-IN"/>
           </a:p>
@@ -999,7 +999,7 @@
           <a:p>
             <a:fld id="{2AF27EEE-1B67-445E-AA5D-351EC91D1DEB}" type="datetimeFigureOut">
               <a:rPr lang="en-IN" smtClean="0"/>
-              <a:t>08-09-2026</a:t>
+              <a:t>29-09-2026</a:t>
             </a:fld>
             <a:endParaRPr lang="en-IN"/>
           </a:p>
@@ -1209,7 +1209,7 @@
           <a:p>
             <a:fld id="{2AF27EEE-1B67-445E-AA5D-351EC91D1DEB}" type="datetimeFigureOut">
               <a:rPr lang="en-IN" smtClean="0"/>
-              <a:t>08-09-2026</a:t>
+              <a:t>29-09-2026</a:t>
             </a:fld>
             <a:endParaRPr lang="en-IN"/>
           </a:p>
@@ -1444,7 +1444,7 @@
           <a:p>
             <a:fld id="{2AF27EEE-1B67-445E-AA5D-351EC91D1DEB}" type="datetimeFigureOut">
               <a:rPr lang="en-IN" smtClean="0"/>
-              <a:t>08-09-2026</a:t>
+              <a:t>29-09-2026</a:t>
             </a:fld>
             <a:endParaRPr lang="en-IN"/>
           </a:p>
@@ -1720,7 +1720,7 @@
           <a:p>
             <a:fld id="{2AF27EEE-1B67-445E-AA5D-351EC91D1DEB}" type="datetimeFigureOut">
               <a:rPr lang="en-IN" smtClean="0"/>
-              <a:t>08-09-2026</a:t>
+              <a:t>29-09-2026</a:t>
             </a:fld>
             <a:endParaRPr lang="en-IN"/>
           </a:p>
@@ -1988,7 +1988,7 @@
           <a:p>
             <a:fld id="{2AF27EEE-1B67-445E-AA5D-351EC91D1DEB}" type="datetimeFigureOut">
               <a:rPr lang="en-IN" smtClean="0"/>
-              <a:t>08-09-2026</a:t>
+              <a:t>29-09-2026</a:t>
             </a:fld>
             <a:endParaRPr lang="en-IN"/>
           </a:p>
@@ -2403,7 +2403,7 @@
           <a:p>
             <a:fld id="{2AF27EEE-1B67-445E-AA5D-351EC91D1DEB}" type="datetimeFigureOut">
               <a:rPr lang="en-IN" smtClean="0"/>
-              <a:t>08-09-2026</a:t>
+              <a:t>29-09-2026</a:t>
             </a:fld>
             <a:endParaRPr lang="en-IN"/>
           </a:p>
@@ -2545,7 +2545,7 @@
           <a:p>
             <a:fld id="{2AF27EEE-1B67-445E-AA5D-351EC91D1DEB}" type="datetimeFigureOut">
               <a:rPr lang="en-IN" smtClean="0"/>
-              <a:t>08-09-2026</a:t>
+              <a:t>29-09-2026</a:t>
             </a:fld>
             <a:endParaRPr lang="en-IN"/>
           </a:p>
@@ -2658,7 +2658,7 @@
           <a:p>
             <a:fld id="{2AF27EEE-1B67-445E-AA5D-351EC91D1DEB}" type="datetimeFigureOut">
               <a:rPr lang="en-IN" smtClean="0"/>
-              <a:t>08-09-2026</a:t>
+              <a:t>29-09-2026</a:t>
             </a:fld>
             <a:endParaRPr lang="en-IN"/>
           </a:p>
@@ -2971,7 +2971,7 @@
           <a:p>
             <a:fld id="{2AF27EEE-1B67-445E-AA5D-351EC91D1DEB}" type="datetimeFigureOut">
               <a:rPr lang="en-IN" smtClean="0"/>
-              <a:t>08-09-2026</a:t>
+              <a:t>29-09-2026</a:t>
             </a:fld>
             <a:endParaRPr lang="en-IN"/>
           </a:p>
@@ -3260,7 +3260,7 @@
           <a:p>
             <a:fld id="{2AF27EEE-1B67-445E-AA5D-351EC91D1DEB}" type="datetimeFigureOut">
               <a:rPr lang="en-IN" smtClean="0"/>
-              <a:t>08-09-2026</a:t>
+              <a:t>29-09-2026</a:t>
             </a:fld>
             <a:endParaRPr lang="en-IN"/>
           </a:p>
@@ -3503,7 +3503,7 @@
           <a:p>
             <a:fld id="{2AF27EEE-1B67-445E-AA5D-351EC91D1DEB}" type="datetimeFigureOut">
               <a:rPr lang="en-IN" smtClean="0"/>
-              <a:t>08-09-2026</a:t>
+              <a:t>29-09-2026</a:t>
             </a:fld>
             <a:endParaRPr lang="en-IN"/>
           </a:p>
@@ -3949,7 +3949,10 @@
         </p:spPr>
         <p:txBody>
           <a:bodyPr/>
-          <a:p/>
+          <a:lstStyle/>
+          <a:p>
+            <a:endParaRPr/>
+          </a:p>
         </p:txBody>
       </p:sp>
       <p:sp>
@@ -4146,17 +4149,18 @@
               </a:spcAft>
               <a:buSzPct val="100000"/>
               <a:buChar char="•"/>
-              <a:defRPr b="1" sz="1600">
+              <a:defRPr sz="1600" b="1">
                 <a:solidFill>
                   <a:srgbClr val="1E293B"/>
                 </a:solidFill>
               </a:defRPr>
             </a:pPr>
             <a:r>
+              <a:rPr dirty="0"/>
               <a:t>Theme ID: </a:t>
             </a:r>
             <a:r>
-              <a:rPr b="0" sz="1600">
+              <a:rPr sz="1600" b="0" dirty="0">
                 <a:solidFill>
                   <a:srgbClr val="1A4B8C"/>
                 </a:solidFill>
@@ -4169,22 +4173,31 @@
               <a:spcAft>
                 <a:spcPts val="800"/>
               </a:spcAft>
-              <a:defRPr b="1" sz="1600">
+              <a:defRPr sz="1600" b="1">
                 <a:solidFill>
                   <a:srgbClr val="1E293B"/>
                 </a:solidFill>
               </a:defRPr>
             </a:pPr>
             <a:r>
+              <a:rPr dirty="0"/>
               <a:t>Project Title: </a:t>
             </a:r>
             <a:r>
-              <a:rPr b="0" sz="1600">
+              <a:rPr sz="1600" b="0" dirty="0" err="1">
                 <a:solidFill>
                   <a:srgbClr val="1A4B8C"/>
                 </a:solidFill>
               </a:rPr>
-              <a:t>FixFlow — Smart Guided Troubleshooting Engine</a:t>
+              <a:t>FixFlow</a:t>
+            </a:r>
+            <a:r>
+              <a:rPr sz="1600" b="0" dirty="0">
+                <a:solidFill>
+                  <a:srgbClr val="1A4B8C"/>
+                </a:solidFill>
+              </a:rPr>
+              <a:t> — Smart Guided Troubleshooting Engine</a:t>
             </a:r>
           </a:p>
           <a:p>
@@ -4192,40 +4205,47 @@
               <a:spcAft>
                 <a:spcPts val="800"/>
               </a:spcAft>
-              <a:defRPr b="1" sz="1600">
+              <a:defRPr sz="1600" b="1">
                 <a:solidFill>
                   <a:srgbClr val="1E293B"/>
                 </a:solidFill>
               </a:defRPr>
             </a:pPr>
             <a:r>
+              <a:rPr dirty="0"/>
               <a:t>Team Name: </a:t>
             </a:r>
             <a:r>
-              <a:rPr b="0" sz="1600">
+              <a:rPr sz="1600" b="0" dirty="0" err="1">
                 <a:solidFill>
                   <a:srgbClr val="1A4B8C"/>
                 </a:solidFill>
               </a:rPr>
-              <a:t>SRMIST_FixFlow</a:t>
-            </a:r>
+              <a:t>FixFlow</a:t>
+            </a:r>
+            <a:endParaRPr sz="1600" b="0" dirty="0">
+              <a:solidFill>
+                <a:srgbClr val="1A4B8C"/>
+              </a:solidFill>
+            </a:endParaRPr>
           </a:p>
           <a:p>
             <a:pPr>
               <a:spcAft>
                 <a:spcPts val="800"/>
               </a:spcAft>
-              <a:defRPr b="1" sz="1600">
+              <a:defRPr sz="1600" b="1">
                 <a:solidFill>
                   <a:srgbClr val="1E293B"/>
                 </a:solidFill>
               </a:defRPr>
             </a:pPr>
             <a:r>
+              <a:rPr dirty="0"/>
               <a:t>College Name: </a:t>
             </a:r>
             <a:r>
-              <a:rPr b="0" sz="1600">
+              <a:rPr sz="1600" b="0" dirty="0">
                 <a:solidFill>
                   <a:srgbClr val="1A4B8C"/>
                 </a:solidFill>
@@ -4238,40 +4258,47 @@
               <a:spcAft>
                 <a:spcPts val="800"/>
               </a:spcAft>
-              <a:defRPr b="1" sz="1600">
+              <a:defRPr sz="1600" b="1">
                 <a:solidFill>
                   <a:srgbClr val="1E293B"/>
                 </a:solidFill>
               </a:defRPr>
             </a:pPr>
             <a:r>
+              <a:rPr dirty="0"/>
               <a:t>Team Lead: </a:t>
             </a:r>
             <a:r>
-              <a:rPr b="0" sz="1600">
+              <a:rPr lang="en-US" sz="1600" dirty="0">
                 <a:solidFill>
                   <a:srgbClr val="1A4B8C"/>
                 </a:solidFill>
               </a:rPr>
-              <a:t>Mridul Mathur (mridul.mat@outlook.com)</a:t>
-            </a:r>
+              <a:t>Hemish Jain</a:t>
+            </a:r>
+            <a:endParaRPr sz="1600" b="0" dirty="0">
+              <a:solidFill>
+                <a:srgbClr val="1A4B8C"/>
+              </a:solidFill>
+            </a:endParaRPr>
           </a:p>
           <a:p>
             <a:pPr>
               <a:spcAft>
                 <a:spcPts val="800"/>
               </a:spcAft>
-              <a:defRPr b="1" sz="1600">
+              <a:defRPr sz="1600" b="1">
                 <a:solidFill>
                   <a:srgbClr val="1E293B"/>
                 </a:solidFill>
               </a:defRPr>
             </a:pPr>
             <a:r>
+              <a:rPr dirty="0"/>
               <a:t>GitHub Repo: </a:t>
             </a:r>
             <a:r>
-              <a:rPr b="0" sz="1600">
+              <a:rPr sz="1600" b="0" dirty="0">
                 <a:solidFill>
                   <a:srgbClr val="1A4B8C"/>
                 </a:solidFill>
@@ -4284,17 +4311,18 @@
               <a:spcAft>
                 <a:spcPts val="800"/>
               </a:spcAft>
-              <a:defRPr b="1" sz="1600">
+              <a:defRPr sz="1600" b="1">
                 <a:solidFill>
                   <a:srgbClr val="1E293B"/>
                 </a:solidFill>
               </a:defRPr>
             </a:pPr>
             <a:r>
+              <a:rPr dirty="0"/>
               <a:t>Official Release Tag: </a:t>
             </a:r>
             <a:r>
-              <a:rPr b="0" sz="1600">
+              <a:rPr sz="1600" b="0" dirty="0">
                 <a:solidFill>
                   <a:srgbClr val="1A4B8C"/>
                 </a:solidFill>
@@ -4401,31 +4429,6 @@
       </p:sp>
       <p:sp>
         <p:nvSpPr>
-          <p:cNvPr id="3" name="Content Placeholder 2">
-            <a:extLst>
-              <a:ext uri="{FF2B5EF4-FFF2-40B4-BE49-F238E27FC236}">
-                <a16:creationId xmlns:a16="http://schemas.microsoft.com/office/drawing/2014/main" id="{539AB598-5650-4E46-905A-9096F4C50C3B}"/>
-              </a:ext>
-            </a:extLst>
-          </p:cNvPr>
-          <p:cNvSpPr>
-            <a:spLocks noGrp="1"/>
-          </p:cNvSpPr>
-          <p:nvPr>
-            <p:ph idx="1"/>
-          </p:nvPr>
-        </p:nvSpPr>
-        <p:spPr/>
-        <p:txBody>
-          <a:bodyPr/>
-          <a:lstStyle/>
-          <a:p>
-            <a:endParaRPr lang="en-IN" dirty="0"/>
-          </a:p>
-        </p:txBody>
-      </p:sp>
-      <p:sp>
-        <p:nvSpPr>
           <p:cNvPr id="4" name="TextBox 3"/>
           <p:cNvSpPr txBox="1"/>
           <p:nvPr/>
@@ -4450,7 +4453,7 @@
               <a:spcAft>
                 <a:spcPts val="1200"/>
               </a:spcAft>
-              <a:defRPr b="1" sz="1600">
+              <a:defRPr sz="1600" b="1">
                 <a:solidFill>
                   <a:srgbClr val="1E293B"/>
                 </a:solidFill>
@@ -4461,7 +4464,7 @@
               <a:t>Freeform Problem Auto-Retrieval: </a:t>
             </a:r>
             <a:r>
-              <a:rPr b="0" sz="1500">
+              <a:rPr sz="1500" b="0">
                 <a:solidFill>
                   <a:srgbClr val="475569"/>
                 </a:solidFill>
@@ -4475,7 +4478,7 @@
               <a:spcAft>
                 <a:spcPts val="1200"/>
               </a:spcAft>
-              <a:defRPr b="1" sz="1600">
+              <a:defRPr sz="1600" b="1">
                 <a:solidFill>
                   <a:srgbClr val="1E293B"/>
                 </a:solidFill>
@@ -4486,7 +4489,7 @@
               <a:t>Interactive Galaxy S24 Simulator: </a:t>
             </a:r>
             <a:r>
-              <a:rPr b="0" sz="1500">
+              <a:rPr sz="1500" b="0">
                 <a:solidFill>
                   <a:srgbClr val="475569"/>
                 </a:solidFill>
@@ -4500,7 +4503,7 @@
               <a:spcAft>
                 <a:spcPts val="1200"/>
               </a:spcAft>
-              <a:defRPr b="1" sz="1600">
+              <a:defRPr sz="1600" b="1">
                 <a:solidFill>
                   <a:srgbClr val="1E293B"/>
                 </a:solidFill>
@@ -4511,7 +4514,7 @@
               <a:t>Hedged Multi-LLM Fallback Chain: </a:t>
             </a:r>
             <a:r>
-              <a:rPr b="0" sz="1500">
+              <a:rPr sz="1500" b="0">
                 <a:solidFill>
                   <a:srgbClr val="475569"/>
                 </a:solidFill>
@@ -4525,7 +4528,7 @@
               <a:spcAft>
                 <a:spcPts val="1200"/>
               </a:spcAft>
-              <a:defRPr b="1" sz="1600">
+              <a:defRPr sz="1600" b="1">
                 <a:solidFill>
                   <a:srgbClr val="1E293B"/>
                 </a:solidFill>
@@ -4536,7 +4539,7 @@
               <a:t>Zero SQLite Locking: </a:t>
             </a:r>
             <a:r>
-              <a:rPr b="0" sz="1500">
+              <a:rPr sz="1500" b="0">
                 <a:solidFill>
                   <a:srgbClr val="475569"/>
                 </a:solidFill>
@@ -4550,7 +4553,7 @@
               <a:spcAft>
                 <a:spcPts val="1200"/>
               </a:spcAft>
-              <a:defRPr b="1" sz="1600">
+              <a:defRPr sz="1600" b="1">
                 <a:solidFill>
                   <a:srgbClr val="1E293B"/>
                 </a:solidFill>
@@ -4561,7 +4564,7 @@
               <a:t>Broadcast-Quality Playwright Automation: </a:t>
             </a:r>
             <a:r>
-              <a:rPr b="0" sz="1500">
+              <a:rPr sz="1500" b="0">
                 <a:solidFill>
                   <a:srgbClr val="475569"/>
                 </a:solidFill>
@@ -4604,166 +4607,6 @@
       </p:grpSpPr>
       <p:sp>
         <p:nvSpPr>
-          <p:cNvPr id="2" name="Title 1">
-            <a:extLst>
-              <a:ext uri="{FF2B5EF4-FFF2-40B4-BE49-F238E27FC236}">
-                <a16:creationId xmlns:a16="http://schemas.microsoft.com/office/drawing/2014/main" id="{2F04E28A-8ABF-4E15-B9E1-B0F49C0EE29F}"/>
-              </a:ext>
-            </a:extLst>
-          </p:cNvPr>
-          <p:cNvSpPr>
-            <a:spLocks noGrp="1"/>
-          </p:cNvSpPr>
-          <p:nvPr>
-            <p:ph type="title"/>
-          </p:nvPr>
-        </p:nvSpPr>
-        <p:spPr/>
-        <p:txBody>
-          <a:bodyPr/>
-          <a:lstStyle/>
-          <a:p>
-            <a:pPr>
-              <a:spcAft>
-                <a:spcPts val="1000"/>
-              </a:spcAft>
-              <a:defRPr b="1" sz="1500">
-                <a:solidFill>
-                  <a:srgbClr val="1E293B"/>
-                </a:solidFill>
-              </a:defRPr>
-            </a:pPr>
-            <a:r>
-              <a:t>Working prototype code — public or shared GitHub repo: </a:t>
-            </a:r>
-            <a:r>
-              <a:rPr b="1" sz="1500">
-                <a:solidFill>
-                  <a:srgbClr val="1A4B8C"/>
-                </a:solidFill>
-              </a:rPr>
-              <a:t>YES (https://github.com/MatMridul/FixFlow)</a:t>
-            </a:r>
-          </a:p>
-          <a:p>
-            <a:pPr>
-              <a:spcAft>
-                <a:spcPts val="1000"/>
-              </a:spcAft>
-              <a:defRPr b="1" sz="1500">
-                <a:solidFill>
-                  <a:srgbClr val="1E293B"/>
-                </a:solidFill>
-              </a:defRPr>
-            </a:pPr>
-            <a:r>
-              <a:t>README with reproducible setup instructions: </a:t>
-            </a:r>
-            <a:r>
-              <a:rPr b="1" sz="1500">
-                <a:solidFill>
-                  <a:srgbClr val="1A4B8C"/>
-                </a:solidFill>
-              </a:rPr>
-              <a:t>YES (README.md with pip, Docker, API curl &amp; test guides)</a:t>
-            </a:r>
-          </a:p>
-          <a:p>
-            <a:pPr>
-              <a:spcAft>
-                <a:spcPts val="1000"/>
-              </a:spcAft>
-              <a:defRPr b="1" sz="1500">
-                <a:solidFill>
-                  <a:srgbClr val="1E293B"/>
-                </a:solidFill>
-              </a:defRPr>
-            </a:pPr>
-            <a:r>
-              <a:t>Demo video, max 5 minutes: </a:t>
-            </a:r>
-            <a:r>
-              <a:rPr b="1" sz="1500">
-                <a:solidFill>
-                  <a:srgbClr val="1A4B8C"/>
-                </a:solidFill>
-              </a:rPr>
-              <a:t>YES (demo-video/FixFlow_Live_Walkthrough_1080p.mp4 - 41.4s, 1080p)</a:t>
-            </a:r>
-          </a:p>
-          <a:p>
-            <a:pPr>
-              <a:spcAft>
-                <a:spcPts val="1000"/>
-              </a:spcAft>
-              <a:defRPr b="1" sz="1500">
-                <a:solidFill>
-                  <a:srgbClr val="1E293B"/>
-                </a:solidFill>
-              </a:defRPr>
-            </a:pPr>
-            <a:r>
-              <a:t>Presentation file (PPT or PDF): </a:t>
-            </a:r>
-            <a:r>
-              <a:rPr b="1" sz="1500">
-                <a:solidFill>
-                  <a:srgbClr val="1A4B8C"/>
-                </a:solidFill>
-              </a:rPr>
-              <a:t>YES (SRMIST_FixFlow_Submission.pptx)</a:t>
-            </a:r>
-          </a:p>
-          <a:p>
-            <a:pPr>
-              <a:spcAft>
-                <a:spcPts val="1000"/>
-              </a:spcAft>
-              <a:defRPr b="1" sz="1500">
-                <a:solidFill>
-                  <a:srgbClr val="1E293B"/>
-                </a:solidFill>
-              </a:defRPr>
-            </a:pPr>
-            <a:r>
-              <a:t>Official Git Release Tag Created &amp; Pushed: </a:t>
-            </a:r>
-            <a:r>
-              <a:rPr b="1" sz="1500">
-                <a:solidFill>
-                  <a:srgbClr val="1A4B8C"/>
-                </a:solidFill>
-              </a:rPr>
-              <a:t>YES (tag: PRISM_GENAI_HACKATHON_Y2026)</a:t>
-            </a:r>
-          </a:p>
-          <a:p>
-            <a:pPr>
-              <a:spcAft>
-                <a:spcPts val="1000"/>
-              </a:spcAft>
-              <a:defRPr b="1" sz="1500">
-                <a:solidFill>
-                  <a:srgbClr val="1E293B"/>
-                </a:solidFill>
-              </a:defRPr>
-            </a:pPr>
-            <a:r>
-              <a:t>Complete Test Suite &amp; Benchmark Metrics: </a:t>
-            </a:r>
-            <a:r>
-              <a:rPr b="1" sz="1500">
-                <a:solidFill>
-                  <a:srgbClr val="1A4B8C"/>
-                </a:solidFill>
-              </a:rPr>
-              <a:t>YES (168/168 tests passing; results.json &amp; metrics.md generated)</a:t>
-            </a:r>
-          </a:p>
-        </p:txBody>
-      </p:sp>
-      <p:sp>
-        <p:nvSpPr>
           <p:cNvPr id="3" name="Content Placeholder 2">
             <a:extLst>
               <a:ext uri="{FF2B5EF4-FFF2-40B4-BE49-F238E27FC236}">
@@ -4778,7 +4621,12 @@
             <p:ph idx="1"/>
           </p:nvPr>
         </p:nvSpPr>
-        <p:spPr/>
+        <p:spPr>
+          <a:xfrm>
+            <a:off x="607017" y="721371"/>
+            <a:ext cx="10515600" cy="2707629"/>
+          </a:xfrm>
+        </p:spPr>
         <p:txBody>
           <a:bodyPr/>
           <a:lstStyle/>
@@ -4789,17 +4637,18 @@
               </a:spcAft>
               <a:buSzPct val="100000"/>
               <a:buChar char="•"/>
-              <a:defRPr b="1" sz="1500">
+              <a:defRPr sz="1500" b="1">
                 <a:solidFill>
                   <a:srgbClr val="1E293B"/>
                 </a:solidFill>
               </a:defRPr>
             </a:pPr>
             <a:r>
+              <a:rPr dirty="0"/>
               <a:t>Working prototype code — public or shared GitHub repo: </a:t>
             </a:r>
             <a:r>
-              <a:rPr b="1" sz="1500">
+              <a:rPr sz="1500" b="1" dirty="0">
                 <a:solidFill>
                   <a:srgbClr val="1A4B8C"/>
                 </a:solidFill>
@@ -4813,17 +4662,18 @@
               <a:spcAft>
                 <a:spcPts val="1000"/>
               </a:spcAft>
-              <a:defRPr b="1" sz="1500">
+              <a:defRPr sz="1500" b="1">
                 <a:solidFill>
                   <a:srgbClr val="1E293B"/>
                 </a:solidFill>
               </a:defRPr>
             </a:pPr>
             <a:r>
+              <a:rPr dirty="0"/>
               <a:t>README with reproducible setup instructions: </a:t>
             </a:r>
             <a:r>
-              <a:rPr b="1" sz="1500">
+              <a:rPr sz="1500" b="1" dirty="0">
                 <a:solidFill>
                   <a:srgbClr val="1A4B8C"/>
                 </a:solidFill>
@@ -4836,17 +4686,18 @@
               <a:spcAft>
                 <a:spcPts val="1000"/>
               </a:spcAft>
-              <a:defRPr b="1" sz="1500">
+              <a:defRPr sz="1500" b="1">
                 <a:solidFill>
                   <a:srgbClr val="1E293B"/>
                 </a:solidFill>
               </a:defRPr>
             </a:pPr>
             <a:r>
+              <a:rPr dirty="0"/>
               <a:t>Demo video, max 5 minutes: </a:t>
             </a:r>
             <a:r>
-              <a:rPr b="1" sz="1500">
+              <a:rPr sz="1500" b="1" dirty="0">
                 <a:solidFill>
                   <a:srgbClr val="1A4B8C"/>
                 </a:solidFill>
@@ -4859,17 +4710,18 @@
               <a:spcAft>
                 <a:spcPts val="1000"/>
               </a:spcAft>
-              <a:defRPr b="1" sz="1500">
+              <a:defRPr sz="1500" b="1">
                 <a:solidFill>
                   <a:srgbClr val="1E293B"/>
                 </a:solidFill>
               </a:defRPr>
             </a:pPr>
             <a:r>
+              <a:rPr dirty="0"/>
               <a:t>Presentation file (PPT or PDF): </a:t>
             </a:r>
             <a:r>
-              <a:rPr b="1" sz="1500">
+              <a:rPr sz="1500" b="1" dirty="0">
                 <a:solidFill>
                   <a:srgbClr val="1A4B8C"/>
                 </a:solidFill>
@@ -4882,17 +4734,18 @@
               <a:spcAft>
                 <a:spcPts val="1000"/>
               </a:spcAft>
-              <a:defRPr b="1" sz="1500">
+              <a:defRPr sz="1500" b="1">
                 <a:solidFill>
                   <a:srgbClr val="1E293B"/>
                 </a:solidFill>
               </a:defRPr>
             </a:pPr>
             <a:r>
+              <a:rPr dirty="0"/>
               <a:t>Official Git Release Tag Created &amp; Pushed: </a:t>
             </a:r>
             <a:r>
-              <a:rPr b="1" sz="1500">
+              <a:rPr sz="1500" b="1" dirty="0">
                 <a:solidFill>
                   <a:srgbClr val="1A4B8C"/>
                 </a:solidFill>
@@ -4905,22 +4758,39 @@
               <a:spcAft>
                 <a:spcPts val="1000"/>
               </a:spcAft>
-              <a:defRPr b="1" sz="1500">
+              <a:defRPr sz="1500" b="1">
                 <a:solidFill>
                   <a:srgbClr val="1E293B"/>
                 </a:solidFill>
               </a:defRPr>
             </a:pPr>
             <a:r>
+              <a:rPr dirty="0"/>
               <a:t>Complete Test Suite &amp; Benchmark Metrics: </a:t>
             </a:r>
             <a:r>
-              <a:rPr b="1" sz="1500">
+              <a:rPr sz="1500" b="1" dirty="0">
                 <a:solidFill>
                   <a:srgbClr val="1A4B8C"/>
                 </a:solidFill>
               </a:rPr>
-              <a:t>YES (168/168 tests passing; results.json &amp; metrics.md generated)</a:t>
+              <a:t>YES (168/168 tests passing; </a:t>
+            </a:r>
+            <a:r>
+              <a:rPr sz="1500" b="1" dirty="0" err="1">
+                <a:solidFill>
+                  <a:srgbClr val="1A4B8C"/>
+                </a:solidFill>
+              </a:rPr>
+              <a:t>results.json</a:t>
+            </a:r>
+            <a:r>
+              <a:rPr sz="1500" b="1" dirty="0">
+                <a:solidFill>
+                  <a:srgbClr val="1A4B8C"/>
+                </a:solidFill>
+              </a:rPr>
+              <a:t> &amp; metrics.md generated)</a:t>
             </a:r>
           </a:p>
         </p:txBody>
@@ -5096,31 +4966,6 @@
       </p:sp>
       <p:sp>
         <p:nvSpPr>
-          <p:cNvPr id="3" name="Content Placeholder 2">
-            <a:extLst>
-              <a:ext uri="{FF2B5EF4-FFF2-40B4-BE49-F238E27FC236}">
-                <a16:creationId xmlns:a16="http://schemas.microsoft.com/office/drawing/2014/main" id="{539AB598-5650-4E46-905A-9096F4C50C3B}"/>
-              </a:ext>
-            </a:extLst>
-          </p:cNvPr>
-          <p:cNvSpPr>
-            <a:spLocks noGrp="1"/>
-          </p:cNvSpPr>
-          <p:nvPr>
-            <p:ph idx="1"/>
-          </p:nvPr>
-        </p:nvSpPr>
-        <p:spPr/>
-        <p:txBody>
-          <a:bodyPr/>
-          <a:lstStyle/>
-          <a:p>
-            <a:endParaRPr lang="en-IN"/>
-          </a:p>
-        </p:txBody>
-      </p:sp>
-      <p:sp>
-        <p:nvSpPr>
           <p:cNvPr id="4" name="TextBox 3"/>
           <p:cNvSpPr txBox="1"/>
           <p:nvPr/>
@@ -5145,7 +4990,7 @@
               <a:spcAft>
                 <a:spcPts val="1200"/>
               </a:spcAft>
-              <a:defRPr b="1" sz="1600">
+              <a:defRPr sz="1600" b="1">
                 <a:solidFill>
                   <a:srgbClr val="1E293B"/>
                 </a:solidFill>
@@ -5156,7 +5001,7 @@
               <a:t>Theme Focus: </a:t>
             </a:r>
             <a:r>
-              <a:rPr b="0" sz="1500">
+              <a:rPr sz="1500" b="0">
                 <a:solidFill>
                   <a:srgbClr val="475569"/>
                 </a:solidFill>
@@ -5170,7 +5015,7 @@
               <a:spcAft>
                 <a:spcPts val="1200"/>
               </a:spcAft>
-              <a:defRPr b="1" sz="1600">
+              <a:defRPr sz="1600" b="1">
                 <a:solidFill>
                   <a:srgbClr val="1E293B"/>
                 </a:solidFill>
@@ -5181,7 +5026,7 @@
               <a:t>The Core Challenge: </a:t>
             </a:r>
             <a:r>
-              <a:rPr b="0" sz="1500">
+              <a:rPr sz="1500" b="0">
                 <a:solidFill>
                   <a:srgbClr val="475569"/>
                 </a:solidFill>
@@ -5195,7 +5040,7 @@
               <a:spcAft>
                 <a:spcPts val="1200"/>
               </a:spcAft>
-              <a:defRPr b="1" sz="1600">
+              <a:defRPr sz="1600" b="1">
                 <a:solidFill>
                   <a:srgbClr val="1E293B"/>
                 </a:solidFill>
@@ -5206,7 +5051,7 @@
               <a:t>The FixFlow Mission: </a:t>
             </a:r>
             <a:r>
-              <a:rPr b="0" sz="1500">
+              <a:rPr sz="1500" b="0">
                 <a:solidFill>
                   <a:srgbClr val="475569"/>
                 </a:solidFill>
@@ -5220,7 +5065,7 @@
               <a:spcAft>
                 <a:spcPts val="1200"/>
               </a:spcAft>
-              <a:defRPr b="1" sz="1600">
+              <a:defRPr sz="1600" b="1">
                 <a:solidFill>
                   <a:srgbClr val="1E293B"/>
                 </a:solidFill>
@@ -5231,7 +5076,7 @@
               <a:t>Four Core Pillars: </a:t>
             </a:r>
             <a:r>
-              <a:rPr b="0" sz="1500">
+              <a:rPr sz="1500" b="0">
                 <a:solidFill>
                   <a:srgbClr val="475569"/>
                 </a:solidFill>
@@ -5245,7 +5090,7 @@
               <a:spcAft>
                 <a:spcPts val="1200"/>
               </a:spcAft>
-              <a:defRPr b="1" sz="1600">
+              <a:defRPr sz="1600" b="1">
                 <a:solidFill>
                   <a:srgbClr val="1E293B"/>
                 </a:solidFill>
@@ -5256,7 +5101,7 @@
               <a:t>Scope &amp; Compliance: </a:t>
             </a:r>
             <a:r>
-              <a:rPr b="0" sz="1500">
+              <a:rPr sz="1500" b="0">
                 <a:solidFill>
                   <a:srgbClr val="475569"/>
                 </a:solidFill>
@@ -5335,31 +5180,6 @@
       </p:sp>
       <p:sp>
         <p:nvSpPr>
-          <p:cNvPr id="3" name="Content Placeholder 2">
-            <a:extLst>
-              <a:ext uri="{FF2B5EF4-FFF2-40B4-BE49-F238E27FC236}">
-                <a16:creationId xmlns:a16="http://schemas.microsoft.com/office/drawing/2014/main" id="{539AB598-5650-4E46-905A-9096F4C50C3B}"/>
-              </a:ext>
-            </a:extLst>
-          </p:cNvPr>
-          <p:cNvSpPr>
-            <a:spLocks noGrp="1"/>
-          </p:cNvSpPr>
-          <p:nvPr>
-            <p:ph idx="1"/>
-          </p:nvPr>
-        </p:nvSpPr>
-        <p:spPr/>
-        <p:txBody>
-          <a:bodyPr/>
-          <a:lstStyle/>
-          <a:p>
-            <a:endParaRPr lang="en-IN"/>
-          </a:p>
-        </p:txBody>
-      </p:sp>
-      <p:sp>
-        <p:nvSpPr>
           <p:cNvPr id="4" name="TextBox 3"/>
           <p:cNvSpPr txBox="1"/>
           <p:nvPr/>
@@ -5384,7 +5204,7 @@
               <a:spcAft>
                 <a:spcPts val="1200"/>
               </a:spcAft>
-              <a:defRPr b="1" sz="1600">
+              <a:defRPr sz="1600" b="1">
                 <a:solidFill>
                   <a:srgbClr val="1E293B"/>
                 </a:solidFill>
@@ -5395,7 +5215,7 @@
               <a:t>Generic LLM Chatbots: </a:t>
             </a:r>
             <a:r>
-              <a:rPr b="0" sz="1500">
+              <a:rPr sz="1500" b="0">
                 <a:solidFill>
                   <a:srgbClr val="475569"/>
                 </a:solidFill>
@@ -5409,7 +5229,7 @@
               <a:spcAft>
                 <a:spcPts val="1200"/>
               </a:spcAft>
-              <a:defRPr b="1" sz="1600">
+              <a:defRPr sz="1600" b="1">
                 <a:solidFill>
                   <a:srgbClr val="1E293B"/>
                 </a:solidFill>
@@ -5420,7 +5240,7 @@
               <a:t>High Latency &amp; High Cost: </a:t>
             </a:r>
             <a:r>
-              <a:rPr b="0" sz="1500">
+              <a:rPr sz="1500" b="0">
                 <a:solidFill>
                   <a:srgbClr val="475569"/>
                 </a:solidFill>
@@ -5434,7 +5254,7 @@
               <a:spcAft>
                 <a:spcPts val="1200"/>
               </a:spcAft>
-              <a:defRPr b="1" sz="1600">
+              <a:defRPr sz="1600" b="1">
                 <a:solidFill>
                   <a:srgbClr val="1E293B"/>
                 </a:solidFill>
@@ -5445,7 +5265,7 @@
               <a:t>Keyword &amp; Rule Engines: </a:t>
             </a:r>
             <a:r>
-              <a:rPr b="0" sz="1500">
+              <a:rPr sz="1500" b="0">
                 <a:solidFill>
                   <a:srgbClr val="475569"/>
                 </a:solidFill>
@@ -5459,7 +5279,7 @@
               <a:spcAft>
                 <a:spcPts val="1200"/>
               </a:spcAft>
-              <a:defRPr b="1" sz="1600">
+              <a:defRPr sz="1600" b="1">
                 <a:solidFill>
                   <a:srgbClr val="1E293B"/>
                 </a:solidFill>
@@ -5470,7 +5290,7 @@
               <a:t>Open-Loop Instructions: </a:t>
             </a:r>
             <a:r>
-              <a:rPr b="0" sz="1500">
+              <a:rPr sz="1500" b="0">
                 <a:solidFill>
                   <a:srgbClr val="475569"/>
                 </a:solidFill>
@@ -5484,7 +5304,7 @@
               <a:spcAft>
                 <a:spcPts val="1200"/>
               </a:spcAft>
-              <a:defRPr b="1" sz="1600">
+              <a:defRPr sz="1600" b="1">
                 <a:solidFill>
                   <a:srgbClr val="1E293B"/>
                 </a:solidFill>
@@ -5495,7 +5315,7 @@
               <a:t>The FixFlow Advantage: </a:t>
             </a:r>
             <a:r>
-              <a:rPr b="0" sz="1500">
+              <a:rPr sz="1500" b="0">
                 <a:solidFill>
                   <a:srgbClr val="475569"/>
                 </a:solidFill>
@@ -5581,31 +5401,6 @@
       </p:sp>
       <p:sp>
         <p:nvSpPr>
-          <p:cNvPr id="3" name="Content Placeholder 2">
-            <a:extLst>
-              <a:ext uri="{FF2B5EF4-FFF2-40B4-BE49-F238E27FC236}">
-                <a16:creationId xmlns:a16="http://schemas.microsoft.com/office/drawing/2014/main" id="{539AB598-5650-4E46-905A-9096F4C50C3B}"/>
-              </a:ext>
-            </a:extLst>
-          </p:cNvPr>
-          <p:cNvSpPr>
-            <a:spLocks noGrp="1"/>
-          </p:cNvSpPr>
-          <p:nvPr>
-            <p:ph idx="1"/>
-          </p:nvPr>
-        </p:nvSpPr>
-        <p:spPr/>
-        <p:txBody>
-          <a:bodyPr/>
-          <a:lstStyle/>
-          <a:p>
-            <a:endParaRPr lang="en-IN"/>
-          </a:p>
-        </p:txBody>
-      </p:sp>
-      <p:sp>
-        <p:nvSpPr>
           <p:cNvPr id="4" name="TextBox 3"/>
           <p:cNvSpPr txBox="1"/>
           <p:nvPr/>
@@ -5630,7 +5425,7 @@
               <a:spcAft>
                 <a:spcPts val="1200"/>
               </a:spcAft>
-              <a:defRPr b="1" sz="1600">
+              <a:defRPr sz="1600" b="1">
                 <a:solidFill>
                   <a:srgbClr val="1E293B"/>
                 </a:solidFill>
@@ -5641,7 +5436,7 @@
               <a:t>0. Query Enrichment (N1 + N2): </a:t>
             </a:r>
             <a:r>
-              <a:rPr b="0" sz="1500">
+              <a:rPr sz="1500" b="0">
                 <a:solidFill>
                   <a:srgbClr val="475569"/>
                 </a:solidFill>
@@ -5655,7 +5450,7 @@
               <a:spcAft>
                 <a:spcPts val="1200"/>
               </a:spcAft>
-              <a:defRPr b="1" sz="1600">
+              <a:defRPr sz="1600" b="1">
                 <a:solidFill>
                   <a:srgbClr val="1E293B"/>
                 </a:solidFill>
@@ -5666,7 +5461,7 @@
               <a:t>1. Compositional Gated Cache (N1 + N2): </a:t>
             </a:r>
             <a:r>
-              <a:rPr b="0" sz="1500">
+              <a:rPr sz="1500" b="0">
                 <a:solidFill>
                   <a:srgbClr val="475569"/>
                 </a:solidFill>
@@ -5680,7 +5475,7 @@
               <a:spcAft>
                 <a:spcPts val="1200"/>
               </a:spcAft>
-              <a:defRPr b="1" sz="1600">
+              <a:defRPr sz="1600" b="1">
                 <a:solidFill>
                   <a:srgbClr val="1E293B"/>
                 </a:solidFill>
@@ -5691,7 +5486,7 @@
               <a:t>2. SIIS Knowledge Auto-Retriever: </a:t>
             </a:r>
             <a:r>
-              <a:rPr b="0" sz="1500">
+              <a:rPr sz="1500" b="0">
                 <a:solidFill>
                   <a:srgbClr val="475569"/>
                 </a:solidFill>
@@ -5705,7 +5500,7 @@
               <a:spcAft>
                 <a:spcPts val="1200"/>
               </a:spcAft>
-              <a:defRPr b="1" sz="1600">
+              <a:defRPr sz="1600" b="1">
                 <a:solidFill>
                   <a:srgbClr val="1E293B"/>
                 </a:solidFill>
@@ -5716,7 +5511,7 @@
               <a:t>3. Structure Extraction &amp; Provenance (N5): </a:t>
             </a:r>
             <a:r>
-              <a:rPr b="0" sz="1500">
+              <a:rPr sz="1500" b="0">
                 <a:solidFill>
                   <a:srgbClr val="475569"/>
                 </a:solidFill>
@@ -5730,7 +5525,7 @@
               <a:spcAft>
                 <a:spcPts val="1200"/>
               </a:spcAft>
-              <a:defRPr b="1" sz="1600">
+              <a:defRPr sz="1600" b="1">
                 <a:solidFill>
                   <a:srgbClr val="1E293B"/>
                 </a:solidFill>
@@ -5741,7 +5536,7 @@
               <a:t>4. Settings Screen Graph Reranker (N3): </a:t>
             </a:r>
             <a:r>
-              <a:rPr b="0" sz="1500">
+              <a:rPr sz="1500" b="0">
                 <a:solidFill>
                   <a:srgbClr val="475569"/>
                 </a:solidFill>
@@ -5755,7 +5550,7 @@
               <a:spcAft>
                 <a:spcPts val="1200"/>
               </a:spcAft>
-              <a:defRPr b="1" sz="1600">
+              <a:defRPr sz="1600" b="1">
                 <a:solidFill>
                   <a:srgbClr val="1E293B"/>
                 </a:solidFill>
@@ -5766,7 +5561,7 @@
               <a:t>5. Closed-Loop Validation &amp; Repair Loop (N4): </a:t>
             </a:r>
             <a:r>
-              <a:rPr b="0" sz="1500">
+              <a:rPr sz="1500" b="0">
                 <a:solidFill>
                   <a:srgbClr val="475569"/>
                 </a:solidFill>
@@ -5842,31 +5637,6 @@
       </p:sp>
       <p:sp>
         <p:nvSpPr>
-          <p:cNvPr id="3" name="Content Placeholder 2">
-            <a:extLst>
-              <a:ext uri="{FF2B5EF4-FFF2-40B4-BE49-F238E27FC236}">
-                <a16:creationId xmlns:a16="http://schemas.microsoft.com/office/drawing/2014/main" id="{539AB598-5650-4E46-905A-9096F4C50C3B}"/>
-              </a:ext>
-            </a:extLst>
-          </p:cNvPr>
-          <p:cNvSpPr>
-            <a:spLocks noGrp="1"/>
-          </p:cNvSpPr>
-          <p:nvPr>
-            <p:ph idx="1"/>
-          </p:nvPr>
-        </p:nvSpPr>
-        <p:spPr/>
-        <p:txBody>
-          <a:bodyPr/>
-          <a:lstStyle/>
-          <a:p>
-            <a:endParaRPr lang="en-IN"/>
-          </a:p>
-        </p:txBody>
-      </p:sp>
-      <p:sp>
-        <p:nvSpPr>
           <p:cNvPr id="4" name="TextBox 3"/>
           <p:cNvSpPr txBox="1"/>
           <p:nvPr/>
@@ -5891,7 +5661,7 @@
               <a:spcAft>
                 <a:spcPts val="1200"/>
               </a:spcAft>
-              <a:defRPr b="1" sz="1600">
+              <a:defRPr sz="1600" b="1">
                 <a:solidFill>
                   <a:srgbClr val="1E293B"/>
                 </a:solidFill>
@@ -5902,7 +5672,7 @@
               <a:t>Interactive Web Interface: </a:t>
             </a:r>
             <a:r>
-              <a:rPr b="0" sz="1500">
+              <a:rPr sz="1500" b="0">
                 <a:solidFill>
                   <a:srgbClr val="475569"/>
                 </a:solidFill>
@@ -5916,7 +5686,7 @@
               <a:spcAft>
                 <a:spcPts val="1200"/>
               </a:spcAft>
-              <a:defRPr b="1" sz="1600">
+              <a:defRPr sz="1600" b="1">
                 <a:solidFill>
                   <a:srgbClr val="1E293B"/>
                 </a:solidFill>
@@ -5927,7 +5697,7 @@
               <a:t>Live Galaxy S24 Device Simulator: </a:t>
             </a:r>
             <a:r>
-              <a:rPr b="0" sz="1500">
+              <a:rPr sz="1500" b="0">
                 <a:solidFill>
                   <a:srgbClr val="475569"/>
                 </a:solidFill>
@@ -5941,7 +5711,7 @@
               <a:spcAft>
                 <a:spcPts val="1200"/>
               </a:spcAft>
-              <a:defRPr b="1" sz="1600">
+              <a:defRPr sz="1600" b="1">
                 <a:solidFill>
                   <a:srgbClr val="1E293B"/>
                 </a:solidFill>
@@ -5952,7 +5722,7 @@
               <a:t>Freeform Problem Entry: </a:t>
             </a:r>
             <a:r>
-              <a:rPr b="0" sz="1500">
+              <a:rPr sz="1500" b="0">
                 <a:solidFill>
                   <a:srgbClr val="475569"/>
                 </a:solidFill>
@@ -5966,7 +5736,7 @@
               <a:spcAft>
                 <a:spcPts val="1200"/>
               </a:spcAft>
-              <a:defRPr b="1" sz="1600">
+              <a:defRPr sz="1600" b="1">
                 <a:solidFill>
                   <a:srgbClr val="1E293B"/>
                 </a:solidFill>
@@ -5977,7 +5747,7 @@
               <a:t>Instant Sub-10ms Cache Hits: </a:t>
             </a:r>
             <a:r>
-              <a:rPr b="0" sz="1500">
+              <a:rPr sz="1500" b="0">
                 <a:solidFill>
                   <a:srgbClr val="475569"/>
                 </a:solidFill>
@@ -5991,7 +5761,7 @@
               <a:spcAft>
                 <a:spcPts val="1200"/>
               </a:spcAft>
-              <a:defRPr b="1" sz="1600">
+              <a:defRPr sz="1600" b="1">
                 <a:solidFill>
                   <a:srgbClr val="1E293B"/>
                 </a:solidFill>
@@ -6002,7 +5772,7 @@
               <a:t>Deep Pipeline Execution Trace: </a:t>
             </a:r>
             <a:r>
-              <a:rPr b="0" sz="1500">
+              <a:rPr sz="1500" b="0">
                 <a:solidFill>
                   <a:srgbClr val="475569"/>
                 </a:solidFill>
@@ -6016,7 +5786,7 @@
               <a:spcAft>
                 <a:spcPts val="1200"/>
               </a:spcAft>
-              <a:defRPr b="1" sz="1600">
+              <a:defRPr sz="1600" b="1">
                 <a:solidFill>
                   <a:srgbClr val="1E293B"/>
                 </a:solidFill>
@@ -6027,7 +5797,7 @@
               <a:t>1080p Walkthrough Video: </a:t>
             </a:r>
             <a:r>
-              <a:rPr b="0" sz="1500">
+              <a:rPr sz="1500" b="0">
                 <a:solidFill>
                   <a:srgbClr val="475569"/>
                 </a:solidFill>
@@ -6110,31 +5880,6 @@
       </p:sp>
       <p:sp>
         <p:nvSpPr>
-          <p:cNvPr id="3" name="Content Placeholder 2">
-            <a:extLst>
-              <a:ext uri="{FF2B5EF4-FFF2-40B4-BE49-F238E27FC236}">
-                <a16:creationId xmlns:a16="http://schemas.microsoft.com/office/drawing/2014/main" id="{539AB598-5650-4E46-905A-9096F4C50C3B}"/>
-              </a:ext>
-            </a:extLst>
-          </p:cNvPr>
-          <p:cNvSpPr>
-            <a:spLocks noGrp="1"/>
-          </p:cNvSpPr>
-          <p:nvPr>
-            <p:ph idx="1"/>
-          </p:nvPr>
-        </p:nvSpPr>
-        <p:spPr/>
-        <p:txBody>
-          <a:bodyPr/>
-          <a:lstStyle/>
-          <a:p>
-            <a:endParaRPr lang="en-IN" dirty="0"/>
-          </a:p>
-        </p:txBody>
-      </p:sp>
-      <p:sp>
-        <p:nvSpPr>
           <p:cNvPr id="4" name="TextBox 3"/>
           <p:cNvSpPr txBox="1"/>
           <p:nvPr/>
@@ -6159,7 +5904,7 @@
               <a:spcAft>
                 <a:spcPts val="1200"/>
               </a:spcAft>
-              <a:defRPr b="1" sz="1600">
+              <a:defRPr sz="1600" b="1">
                 <a:solidFill>
                   <a:srgbClr val="1E293B"/>
                 </a:solidFill>
@@ -6170,7 +5915,7 @@
               <a:t>Backend Core: </a:t>
             </a:r>
             <a:r>
-              <a:rPr b="0" sz="1500">
+              <a:rPr sz="1500" b="0">
                 <a:solidFill>
                   <a:srgbClr val="475569"/>
                 </a:solidFill>
@@ -6184,7 +5929,7 @@
               <a:spcAft>
                 <a:spcPts val="1200"/>
               </a:spcAft>
-              <a:defRPr b="1" sz="1600">
+              <a:defRPr sz="1600" b="1">
                 <a:solidFill>
                   <a:srgbClr val="1E293B"/>
                 </a:solidFill>
@@ -6195,7 +5940,7 @@
               <a:t>LLM Inference Chain: </a:t>
             </a:r>
             <a:r>
-              <a:rPr b="0" sz="1500">
+              <a:rPr sz="1500" b="0">
                 <a:solidFill>
                   <a:srgbClr val="475569"/>
                 </a:solidFill>
@@ -6209,7 +5954,7 @@
               <a:spcAft>
                 <a:spcPts val="1200"/>
               </a:spcAft>
-              <a:defRPr b="1" sz="1600">
+              <a:defRPr sz="1600" b="1">
                 <a:solidFill>
                   <a:srgbClr val="1E293B"/>
                 </a:solidFill>
@@ -6220,7 +5965,7 @@
               <a:t>Deterministic Fallback: </a:t>
             </a:r>
             <a:r>
-              <a:rPr b="0" sz="1500">
+              <a:rPr sz="1500" b="0">
                 <a:solidFill>
                   <a:srgbClr val="475569"/>
                 </a:solidFill>
@@ -6234,7 +5979,7 @@
               <a:spcAft>
                 <a:spcPts val="1200"/>
               </a:spcAft>
-              <a:defRPr b="1" sz="1600">
+              <a:defRPr sz="1600" b="1">
                 <a:solidFill>
                   <a:srgbClr val="1E293B"/>
                 </a:solidFill>
@@ -6245,7 +5990,7 @@
               <a:t>Information Retrieval &amp; Graph: </a:t>
             </a:r>
             <a:r>
-              <a:rPr b="0" sz="1500">
+              <a:rPr sz="1500" b="0">
                 <a:solidFill>
                   <a:srgbClr val="475569"/>
                 </a:solidFill>
@@ -6259,7 +6004,7 @@
               <a:spcAft>
                 <a:spcPts val="1200"/>
               </a:spcAft>
-              <a:defRPr b="1" sz="1600">
+              <a:defRPr sz="1600" b="1">
                 <a:solidFill>
                   <a:srgbClr val="1E293B"/>
                 </a:solidFill>
@@ -6270,7 +6015,7 @@
               <a:t>Storage &amp; Caching: </a:t>
             </a:r>
             <a:r>
-              <a:rPr b="0" sz="1500">
+              <a:rPr sz="1500" b="0">
                 <a:solidFill>
                   <a:srgbClr val="475569"/>
                 </a:solidFill>
@@ -6284,7 +6029,7 @@
               <a:spcAft>
                 <a:spcPts val="1200"/>
               </a:spcAft>
-              <a:defRPr b="1" sz="1600">
+              <a:defRPr sz="1600" b="1">
                 <a:solidFill>
                   <a:srgbClr val="1E293B"/>
                 </a:solidFill>
@@ -6295,7 +6040,7 @@
               <a:t>Testing &amp; Media Pipeline: </a:t>
             </a:r>
             <a:r>
-              <a:rPr b="0" sz="1500">
+              <a:rPr sz="1500" b="0">
                 <a:solidFill>
                   <a:srgbClr val="475569"/>
                 </a:solidFill>
@@ -6378,31 +6123,6 @@
       </p:sp>
       <p:sp>
         <p:nvSpPr>
-          <p:cNvPr id="3" name="Content Placeholder 2">
-            <a:extLst>
-              <a:ext uri="{FF2B5EF4-FFF2-40B4-BE49-F238E27FC236}">
-                <a16:creationId xmlns:a16="http://schemas.microsoft.com/office/drawing/2014/main" id="{539AB598-5650-4E46-905A-9096F4C50C3B}"/>
-              </a:ext>
-            </a:extLst>
-          </p:cNvPr>
-          <p:cNvSpPr>
-            <a:spLocks noGrp="1"/>
-          </p:cNvSpPr>
-          <p:nvPr>
-            <p:ph idx="1"/>
-          </p:nvPr>
-        </p:nvSpPr>
-        <p:spPr/>
-        <p:txBody>
-          <a:bodyPr/>
-          <a:lstStyle/>
-          <a:p>
-            <a:endParaRPr lang="en-IN" dirty="0"/>
-          </a:p>
-        </p:txBody>
-      </p:sp>
-      <p:sp>
-        <p:nvSpPr>
           <p:cNvPr id="4" name="TextBox 3"/>
           <p:cNvSpPr txBox="1"/>
           <p:nvPr/>
@@ -6427,7 +6147,7 @@
               <a:spcAft>
                 <a:spcPts val="1200"/>
               </a:spcAft>
-              <a:defRPr b="1" sz="1600">
+              <a:defRPr sz="1600" b="1">
                 <a:solidFill>
                   <a:srgbClr val="1E293B"/>
                 </a:solidFill>
@@ -6438,7 +6158,7 @@
               <a:t>Customer Support Triage: </a:t>
             </a:r>
             <a:r>
-              <a:rPr b="0" sz="1500">
+              <a:rPr sz="1500" b="0">
                 <a:solidFill>
                   <a:srgbClr val="475569"/>
                 </a:solidFill>
@@ -6452,7 +6172,7 @@
               <a:spcAft>
                 <a:spcPts val="1200"/>
               </a:spcAft>
-              <a:defRPr b="1" sz="1600">
+              <a:defRPr sz="1600" b="1">
                 <a:solidFill>
                   <a:srgbClr val="1E293B"/>
                 </a:solidFill>
@@ -6463,7 +6183,7 @@
               <a:t>Dramatic Cost Reduction: </a:t>
             </a:r>
             <a:r>
-              <a:rPr b="0" sz="1500">
+              <a:rPr sz="1500" b="0">
                 <a:solidFill>
                   <a:srgbClr val="475569"/>
                 </a:solidFill>
@@ -6477,7 +6197,7 @@
               <a:spcAft>
                 <a:spcPts val="1200"/>
               </a:spcAft>
-              <a:defRPr b="1" sz="1600">
+              <a:defRPr sz="1600" b="1">
                 <a:solidFill>
                   <a:srgbClr val="1E293B"/>
                 </a:solidFill>
@@ -6488,7 +6208,7 @@
               <a:t>Frictionless Resolution: </a:t>
             </a:r>
             <a:r>
-              <a:rPr b="0" sz="1500">
+              <a:rPr sz="1500" b="0">
                 <a:solidFill>
                   <a:srgbClr val="475569"/>
                 </a:solidFill>
@@ -6502,7 +6222,7 @@
               <a:spcAft>
                 <a:spcPts val="1200"/>
               </a:spcAft>
-              <a:defRPr b="1" sz="1600">
+              <a:defRPr sz="1600" b="1">
                 <a:solidFill>
                   <a:srgbClr val="1E293B"/>
                 </a:solidFill>
@@ -6513,7 +6233,7 @@
               <a:t>Closed-Loop Self-Verification: </a:t>
             </a:r>
             <a:r>
-              <a:rPr b="0" sz="1500">
+              <a:rPr sz="1500" b="0">
                 <a:solidFill>
                   <a:srgbClr val="475569"/>
                 </a:solidFill>
@@ -6527,7 +6247,7 @@
               <a:spcAft>
                 <a:spcPts val="1200"/>
               </a:spcAft>
-              <a:defRPr b="1" sz="1600">
+              <a:defRPr sz="1600" b="1">
                 <a:solidFill>
                   <a:srgbClr val="1E293B"/>
                 </a:solidFill>
@@ -6538,7 +6258,7 @@
               <a:t>Enterprise Scalability: </a:t>
             </a:r>
             <a:r>
-              <a:rPr b="0" sz="1500">
+              <a:rPr sz="1500" b="0">
                 <a:solidFill>
                   <a:srgbClr val="475569"/>
                 </a:solidFill>
@@ -6627,31 +6347,6 @@
       </p:sp>
       <p:sp>
         <p:nvSpPr>
-          <p:cNvPr id="3" name="Content Placeholder 2">
-            <a:extLst>
-              <a:ext uri="{FF2B5EF4-FFF2-40B4-BE49-F238E27FC236}">
-                <a16:creationId xmlns:a16="http://schemas.microsoft.com/office/drawing/2014/main" id="{539AB598-5650-4E46-905A-9096F4C50C3B}"/>
-              </a:ext>
-            </a:extLst>
-          </p:cNvPr>
-          <p:cNvSpPr>
-            <a:spLocks noGrp="1"/>
-          </p:cNvSpPr>
-          <p:nvPr>
-            <p:ph idx="1"/>
-          </p:nvPr>
-        </p:nvSpPr>
-        <p:spPr/>
-        <p:txBody>
-          <a:bodyPr/>
-          <a:lstStyle/>
-          <a:p>
-            <a:endParaRPr lang="en-IN" dirty="0"/>
-          </a:p>
-        </p:txBody>
-      </p:sp>
-      <p:sp>
-        <p:nvSpPr>
           <p:cNvPr id="4" name="TextBox 3"/>
           <p:cNvSpPr txBox="1"/>
           <p:nvPr/>
@@ -6676,7 +6371,7 @@
               <a:spcAft>
                 <a:spcPts val="1200"/>
               </a:spcAft>
-              <a:defRPr b="1" sz="1600">
+              <a:defRPr sz="1600" b="1">
                 <a:solidFill>
                   <a:srgbClr val="1E293B"/>
                 </a:solidFill>
@@ -6684,10 +6379,11 @@
               </a:defRPr>
             </a:pPr>
             <a:r>
+              <a:rPr dirty="0"/>
               <a:t>Innovation N1 &amp; N2: </a:t>
             </a:r>
             <a:r>
-              <a:rPr b="0" sz="1500">
+              <a:rPr sz="1500" b="0" dirty="0">
                 <a:solidFill>
                   <a:srgbClr val="475569"/>
                 </a:solidFill>
@@ -6701,7 +6397,7 @@
               <a:spcAft>
                 <a:spcPts val="1200"/>
               </a:spcAft>
-              <a:defRPr b="1" sz="1600">
+              <a:defRPr sz="1600" b="1">
                 <a:solidFill>
                   <a:srgbClr val="1E293B"/>
                 </a:solidFill>
@@ -6709,16 +6405,35 @@
               </a:defRPr>
             </a:pPr>
             <a:r>
+              <a:rPr dirty="0"/>
               <a:t>Innovation N3 &amp; N4: </a:t>
             </a:r>
             <a:r>
-              <a:rPr b="0" sz="1500">
+              <a:rPr sz="1500" b="0" dirty="0">
                 <a:solidFill>
                   <a:srgbClr val="475569"/>
                 </a:solidFill>
                 <a:latin typeface="Arial"/>
               </a:rPr>
-              <a:t>Settings Screen Graph path reranking &amp; Closed-Loop self-verifying validation deeplinks.</a:t>
+              <a:t>Settings Screen Graph path reranking &amp; Closed-Loop self-verifying validation </a:t>
+            </a:r>
+            <a:r>
+              <a:rPr sz="1500" b="0" dirty="0" err="1">
+                <a:solidFill>
+                  <a:srgbClr val="475569"/>
+                </a:solidFill>
+                <a:latin typeface="Arial"/>
+              </a:rPr>
+              <a:t>deeplinks</a:t>
+            </a:r>
+            <a:r>
+              <a:rPr sz="1500" b="0" dirty="0">
+                <a:solidFill>
+                  <a:srgbClr val="475569"/>
+                </a:solidFill>
+                <a:latin typeface="Arial"/>
+              </a:rPr>
+              <a:t>.</a:t>
             </a:r>
           </a:p>
           <a:p>
@@ -6726,7 +6441,7 @@
               <a:spcAft>
                 <a:spcPts val="1200"/>
               </a:spcAft>
-              <a:defRPr b="1" sz="1600">
+              <a:defRPr sz="1600" b="1">
                 <a:solidFill>
                   <a:srgbClr val="1E293B"/>
                 </a:solidFill>
@@ -6734,10 +6449,11 @@
               </a:defRPr>
             </a:pPr>
             <a:r>
+              <a:rPr dirty="0"/>
               <a:t>Innovation N5: </a:t>
             </a:r>
             <a:r>
-              <a:rPr b="0" sz="1500">
+              <a:rPr sz="1500" b="0" dirty="0">
                 <a:solidFill>
                   <a:srgbClr val="475569"/>
                 </a:solidFill>
@@ -6751,7 +6467,7 @@
               <a:spcAft>
                 <a:spcPts val="1200"/>
               </a:spcAft>
-              <a:defRPr b="1" sz="1600">
+              <a:defRPr sz="1600" b="1">
                 <a:solidFill>
                   <a:srgbClr val="1E293B"/>
                 </a:solidFill>
@@ -6759,16 +6475,35 @@
               </a:defRPr>
             </a:pPr>
             <a:r>
+              <a:rPr dirty="0"/>
               <a:t>Quantitative Results: </a:t>
             </a:r>
             <a:r>
-              <a:rPr b="0" sz="1500">
+              <a:rPr sz="1500" b="0" dirty="0">
                 <a:solidFill>
                   <a:srgbClr val="475569"/>
                 </a:solidFill>
                 <a:latin typeface="Arial"/>
               </a:rPr>
-              <a:t>168 / 168 passing automated tests; 100% Pydantic schema compliance; 1.5ms – 1.85ms P95 cache latency (exceeds ≤300ms requirement).</a:t>
+              <a:t>168 / 168 passing automated tests; 100% </a:t>
+            </a:r>
+            <a:r>
+              <a:rPr sz="1500" b="0" dirty="0" err="1">
+                <a:solidFill>
+                  <a:srgbClr val="475569"/>
+                </a:solidFill>
+                <a:latin typeface="Arial"/>
+              </a:rPr>
+              <a:t>Pydantic</a:t>
+            </a:r>
+            <a:r>
+              <a:rPr sz="1500" b="0" dirty="0">
+                <a:solidFill>
+                  <a:srgbClr val="475569"/>
+                </a:solidFill>
+                <a:latin typeface="Arial"/>
+              </a:rPr>
+              <a:t> schema compliance; 1.5ms – 1.85ms P95 cache latency (exceeds ≤300ms requirement).</a:t>
             </a:r>
           </a:p>
           <a:p>
@@ -6776,7 +6511,7 @@
               <a:spcAft>
                 <a:spcPts val="1200"/>
               </a:spcAft>
-              <a:defRPr b="1" sz="1600">
+              <a:defRPr sz="1600" b="1">
                 <a:solidFill>
                   <a:srgbClr val="1E293B"/>
                 </a:solidFill>
@@ -6784,10 +6519,11 @@
               </a:defRPr>
             </a:pPr>
             <a:r>
+              <a:rPr dirty="0"/>
               <a:t>Un-Vibe Code Audit: </a:t>
             </a:r>
             <a:r>
-              <a:rPr b="0" sz="1500">
+              <a:rPr sz="1500" b="0" dirty="0">
                 <a:solidFill>
                   <a:srgbClr val="475569"/>
                 </a:solidFill>
@@ -6801,7 +6537,7 @@
               <a:spcAft>
                 <a:spcPts val="1200"/>
               </a:spcAft>
-              <a:defRPr b="1" sz="1600">
+              <a:defRPr sz="1600" b="1">
                 <a:solidFill>
                   <a:srgbClr val="1E293B"/>
                 </a:solidFill>
@@ -6809,10 +6545,11 @@
               </a:defRPr>
             </a:pPr>
             <a:r>
+              <a:rPr dirty="0"/>
               <a:t>Known Limitations: </a:t>
             </a:r>
             <a:r>
-              <a:rPr b="0" sz="1500">
+              <a:rPr sz="1500" b="0" dirty="0">
                 <a:solidFill>
                   <a:srgbClr val="475569"/>
                 </a:solidFill>
@@ -6901,31 +6638,6 @@
       </p:sp>
       <p:sp>
         <p:nvSpPr>
-          <p:cNvPr id="3" name="Content Placeholder 2">
-            <a:extLst>
-              <a:ext uri="{FF2B5EF4-FFF2-40B4-BE49-F238E27FC236}">
-                <a16:creationId xmlns:a16="http://schemas.microsoft.com/office/drawing/2014/main" id="{539AB598-5650-4E46-905A-9096F4C50C3B}"/>
-              </a:ext>
-            </a:extLst>
-          </p:cNvPr>
-          <p:cNvSpPr>
-            <a:spLocks noGrp="1"/>
-          </p:cNvSpPr>
-          <p:nvPr>
-            <p:ph idx="1"/>
-          </p:nvPr>
-        </p:nvSpPr>
-        <p:spPr/>
-        <p:txBody>
-          <a:bodyPr/>
-          <a:lstStyle/>
-          <a:p>
-            <a:endParaRPr lang="en-IN" dirty="0"/>
-          </a:p>
-        </p:txBody>
-      </p:sp>
-      <p:sp>
-        <p:nvSpPr>
           <p:cNvPr id="4" name="TextBox 3"/>
           <p:cNvSpPr txBox="1"/>
           <p:nvPr/>
@@ -6950,7 +6662,7 @@
               <a:spcAft>
                 <a:spcPts val="1200"/>
               </a:spcAft>
-              <a:defRPr b="1" sz="1600">
+              <a:defRPr sz="1600" b="1">
                 <a:solidFill>
                   <a:srgbClr val="1E293B"/>
                 </a:solidFill>
@@ -6958,16 +6670,35 @@
               </a:defRPr>
             </a:pPr>
             <a:r>
+              <a:rPr dirty="0"/>
               <a:t>On-Device Small Language Models: </a:t>
             </a:r>
             <a:r>
-              <a:rPr b="0" sz="1500">
+              <a:rPr sz="1500" b="0" dirty="0">
                 <a:solidFill>
                   <a:srgbClr val="475569"/>
                 </a:solidFill>
                 <a:latin typeface="Arial"/>
               </a:rPr>
-              <a:t>Quantize and deploy Gemma 2B / MobileBERT locally inside One UI for instant offline troubleshooting without cloud dependencies.</a:t>
+              <a:t>Quantize and deploy Gemma 2B / </a:t>
+            </a:r>
+            <a:r>
+              <a:rPr sz="1500" b="0" dirty="0" err="1">
+                <a:solidFill>
+                  <a:srgbClr val="475569"/>
+                </a:solidFill>
+                <a:latin typeface="Arial"/>
+              </a:rPr>
+              <a:t>MobileBERT</a:t>
+            </a:r>
+            <a:r>
+              <a:rPr sz="1500" b="0" dirty="0">
+                <a:solidFill>
+                  <a:srgbClr val="475569"/>
+                </a:solidFill>
+                <a:latin typeface="Arial"/>
+              </a:rPr>
+              <a:t> locally inside One UI for instant offline troubleshooting without cloud dependencies.</a:t>
             </a:r>
           </a:p>
           <a:p>
@@ -6975,7 +6706,7 @@
               <a:spcAft>
                 <a:spcPts val="1200"/>
               </a:spcAft>
-              <a:defRPr b="1" sz="1600">
+              <a:defRPr sz="1600" b="1">
                 <a:solidFill>
                   <a:srgbClr val="1E293B"/>
                 </a:solidFill>
@@ -6983,10 +6714,11 @@
               </a:defRPr>
             </a:pPr>
             <a:r>
+              <a:rPr dirty="0"/>
               <a:t>Multi-Modal Diagnostic Vision: </a:t>
             </a:r>
             <a:r>
-              <a:rPr b="0" sz="1500">
+              <a:rPr sz="1500" b="0" dirty="0">
                 <a:solidFill>
                   <a:srgbClr val="475569"/>
                 </a:solidFill>
@@ -7000,7 +6732,7 @@
               <a:spcAft>
                 <a:spcPts val="1200"/>
               </a:spcAft>
-              <a:defRPr b="1" sz="1600">
+              <a:defRPr sz="1600" b="1">
                 <a:solidFill>
                   <a:srgbClr val="1E293B"/>
                 </a:solidFill>
@@ -7008,10 +6740,11 @@
               </a:defRPr>
             </a:pPr>
             <a:r>
+              <a:rPr dirty="0"/>
               <a:t>Cross-Ecosystem Expansion: </a:t>
             </a:r>
             <a:r>
-              <a:rPr b="0" sz="1500">
+              <a:rPr sz="1500" b="0" dirty="0">
                 <a:solidFill>
                   <a:srgbClr val="475569"/>
                 </a:solidFill>
@@ -7025,7 +6758,7 @@
               <a:spcAft>
                 <a:spcPts val="1200"/>
               </a:spcAft>
-              <a:defRPr b="1" sz="1600">
+              <a:defRPr sz="1600" b="1">
                 <a:solidFill>
                   <a:srgbClr val="1E293B"/>
                 </a:solidFill>
@@ -7033,10 +6766,11 @@
               </a:defRPr>
             </a:pPr>
             <a:r>
+              <a:rPr dirty="0"/>
               <a:t>Bixby Voice Integration: </a:t>
             </a:r>
             <a:r>
-              <a:rPr b="0" sz="1500">
+              <a:rPr sz="1500" b="0" dirty="0">
                 <a:solidFill>
                   <a:srgbClr val="475569"/>
                 </a:solidFill>

</xml_diff>